<commit_message>
Update Tableau outputs and clean presentation metadata
</commit_message>
<xml_diff>
--- a/Olist_Delivery_Intelligence_Presentation.pptx
+++ b/Olist_Delivery_Intelligence_Presentation.pptx
@@ -225,7 +225,7 @@
           <a:p>
             <a:fld id="{F12BB531-2AEC-4DA7-A960-AC7ACF6E8278}" type="datetimeFigureOut">
               <a:rPr lang="en-US" smtClean="0"/>
-              <a:t>4/8/2026</a:t>
+              <a:t>4/9/2026</a:t>
             </a:fld>
             <a:endParaRPr lang="en-US"/>
           </a:p>
@@ -543,7 +543,15 @@
           <a:bodyPr/>
           <a:lstStyle/>
           <a:p>
-            <a:endParaRPr lang="en-US" dirty="0"/>
+            <a:endParaRPr lang="en-US" sz="1200" kern="1200" dirty="0">
+              <a:solidFill>
+                <a:schemeClr val="tx1"/>
+              </a:solidFill>
+              <a:effectLst/>
+              <a:latin typeface="+mn-lt"/>
+              <a:ea typeface="+mn-ea"/>
+              <a:cs typeface="+mn-cs"/>
+            </a:endParaRPr>
           </a:p>
         </p:txBody>
       </p:sp>
@@ -611,13 +619,6 @@
           </p:nvPr>
         </p:nvSpPr>
         <p:spPr/>
-        <p:txBody>
-          <a:bodyPr/>
-          <a:lstStyle/>
-          <a:p>
-            <a:endParaRPr lang="en-US"/>
-          </a:p>
-        </p:txBody>
       </p:sp>
       <p:sp>
         <p:nvSpPr>
@@ -655,6 +656,531 @@
           <a:p>
             <a:fld id="{58A32FB6-50F4-4669-AE20-71D0E9BDB9B1}" type="slidenum">
               <a:rPr lang="en-US" smtClean="0"/>
+              <a:t>10</a:t>
+            </a:fld>
+            <a:endParaRPr lang="en-US"/>
+          </a:p>
+        </p:txBody>
+      </p:sp>
+    </p:spTree>
+    <p:extLst>
+      <p:ext uri="{BB962C8B-B14F-4D97-AF65-F5344CB8AC3E}">
+        <p14:creationId xmlns:p14="http://schemas.microsoft.com/office/powerpoint/2010/main" val="3875492319"/>
+      </p:ext>
+    </p:extLst>
+  </p:cSld>
+  <p:clrMapOvr>
+    <a:masterClrMapping/>
+  </p:clrMapOvr>
+</p:notes>
+</file>
+
+<file path=ppt/notesSlides/notesSlide11.xml><?xml version="1.0" encoding="utf-8"?>
+<p:notes xmlns:a="http://schemas.openxmlformats.org/drawingml/2006/main" xmlns:r="http://schemas.openxmlformats.org/officeDocument/2006/relationships" xmlns:p="http://schemas.openxmlformats.org/presentationml/2006/main">
+  <p:cSld>
+    <p:spTree>
+      <p:nvGrpSpPr>
+        <p:cNvPr id="1" name=""/>
+        <p:cNvGrpSpPr/>
+        <p:nvPr/>
+      </p:nvGrpSpPr>
+      <p:grpSpPr>
+        <a:xfrm>
+          <a:off x="0" y="0"/>
+          <a:ext cx="0" cy="0"/>
+          <a:chOff x="0" y="0"/>
+          <a:chExt cx="0" cy="0"/>
+        </a:xfrm>
+      </p:grpSpPr>
+      <p:sp>
+        <p:nvSpPr>
+          <p:cNvPr id="2" name="Slide Image Placeholder 1"/>
+          <p:cNvSpPr>
+            <a:spLocks noGrp="1" noRot="1" noChangeAspect="1"/>
+          </p:cNvSpPr>
+          <p:nvPr>
+            <p:ph type="sldImg"/>
+          </p:nvPr>
+        </p:nvSpPr>
+        <p:spPr/>
+        <p:txBody>
+          <a:bodyPr/>
+          <a:lstStyle/>
+          <a:p>
+            <a:endParaRPr lang="en-US"/>
+          </a:p>
+        </p:txBody>
+      </p:sp>
+      <p:sp>
+        <p:nvSpPr>
+          <p:cNvPr id="3" name="Notes Placeholder 2"/>
+          <p:cNvSpPr>
+            <a:spLocks noGrp="1"/>
+          </p:cNvSpPr>
+          <p:nvPr>
+            <p:ph type="body" idx="1"/>
+          </p:nvPr>
+        </p:nvSpPr>
+        <p:spPr/>
+        <p:txBody>
+          <a:bodyPr/>
+          <a:lstStyle/>
+          <a:p>
+            <a:endParaRPr lang="en-US" dirty="0"/>
+          </a:p>
+        </p:txBody>
+      </p:sp>
+      <p:sp>
+        <p:nvSpPr>
+          <p:cNvPr id="4" name="Slide Number Placeholder 3"/>
+          <p:cNvSpPr>
+            <a:spLocks noGrp="1"/>
+          </p:cNvSpPr>
+          <p:nvPr>
+            <p:ph type="sldNum" sz="quarter" idx="5"/>
+          </p:nvPr>
+        </p:nvSpPr>
+        <p:spPr/>
+        <p:txBody>
+          <a:bodyPr/>
+          <a:lstStyle/>
+          <a:p>
+            <a:fld id="{58A32FB6-50F4-4669-AE20-71D0E9BDB9B1}" type="slidenum">
+              <a:rPr lang="en-US" smtClean="0"/>
+              <a:t>11</a:t>
+            </a:fld>
+            <a:endParaRPr lang="en-US"/>
+          </a:p>
+        </p:txBody>
+      </p:sp>
+    </p:spTree>
+    <p:extLst>
+      <p:ext uri="{BB962C8B-B14F-4D97-AF65-F5344CB8AC3E}">
+        <p14:creationId xmlns:p14="http://schemas.microsoft.com/office/powerpoint/2010/main" val="98056021"/>
+      </p:ext>
+    </p:extLst>
+  </p:cSld>
+  <p:clrMapOvr>
+    <a:masterClrMapping/>
+  </p:clrMapOvr>
+</p:notes>
+</file>
+
+<file path=ppt/notesSlides/notesSlide12.xml><?xml version="1.0" encoding="utf-8"?>
+<p:notes xmlns:a="http://schemas.openxmlformats.org/drawingml/2006/main" xmlns:r="http://schemas.openxmlformats.org/officeDocument/2006/relationships" xmlns:p="http://schemas.openxmlformats.org/presentationml/2006/main">
+  <p:cSld>
+    <p:spTree>
+      <p:nvGrpSpPr>
+        <p:cNvPr id="1" name=""/>
+        <p:cNvGrpSpPr/>
+        <p:nvPr/>
+      </p:nvGrpSpPr>
+      <p:grpSpPr>
+        <a:xfrm>
+          <a:off x="0" y="0"/>
+          <a:ext cx="0" cy="0"/>
+          <a:chOff x="0" y="0"/>
+          <a:chExt cx="0" cy="0"/>
+        </a:xfrm>
+      </p:grpSpPr>
+      <p:sp>
+        <p:nvSpPr>
+          <p:cNvPr id="2" name="Slide Image Placeholder 1"/>
+          <p:cNvSpPr>
+            <a:spLocks noGrp="1" noRot="1" noChangeAspect="1"/>
+          </p:cNvSpPr>
+          <p:nvPr>
+            <p:ph type="sldImg"/>
+          </p:nvPr>
+        </p:nvSpPr>
+        <p:spPr/>
+        <p:txBody>
+          <a:bodyPr/>
+          <a:lstStyle/>
+          <a:p>
+            <a:endParaRPr lang="en-US"/>
+          </a:p>
+        </p:txBody>
+      </p:sp>
+      <p:sp>
+        <p:nvSpPr>
+          <p:cNvPr id="3" name="Notes Placeholder 2"/>
+          <p:cNvSpPr>
+            <a:spLocks noGrp="1"/>
+          </p:cNvSpPr>
+          <p:nvPr>
+            <p:ph type="body" idx="1"/>
+          </p:nvPr>
+        </p:nvSpPr>
+        <p:spPr/>
+        <p:txBody>
+          <a:bodyPr/>
+          <a:lstStyle/>
+          <a:p>
+            <a:endParaRPr lang="en-US" dirty="0"/>
+          </a:p>
+        </p:txBody>
+      </p:sp>
+      <p:sp>
+        <p:nvSpPr>
+          <p:cNvPr id="4" name="Slide Number Placeholder 3"/>
+          <p:cNvSpPr>
+            <a:spLocks noGrp="1"/>
+          </p:cNvSpPr>
+          <p:nvPr>
+            <p:ph type="sldNum" sz="quarter" idx="5"/>
+          </p:nvPr>
+        </p:nvSpPr>
+        <p:spPr/>
+        <p:txBody>
+          <a:bodyPr/>
+          <a:lstStyle/>
+          <a:p>
+            <a:fld id="{58A32FB6-50F4-4669-AE20-71D0E9BDB9B1}" type="slidenum">
+              <a:rPr lang="en-US" smtClean="0"/>
+              <a:t>12</a:t>
+            </a:fld>
+            <a:endParaRPr lang="en-US"/>
+          </a:p>
+        </p:txBody>
+      </p:sp>
+    </p:spTree>
+    <p:extLst>
+      <p:ext uri="{BB962C8B-B14F-4D97-AF65-F5344CB8AC3E}">
+        <p14:creationId xmlns:p14="http://schemas.microsoft.com/office/powerpoint/2010/main" val="1344464461"/>
+      </p:ext>
+    </p:extLst>
+  </p:cSld>
+  <p:clrMapOvr>
+    <a:masterClrMapping/>
+  </p:clrMapOvr>
+</p:notes>
+</file>
+
+<file path=ppt/notesSlides/notesSlide13.xml><?xml version="1.0" encoding="utf-8"?>
+<p:notes xmlns:a="http://schemas.openxmlformats.org/drawingml/2006/main" xmlns:r="http://schemas.openxmlformats.org/officeDocument/2006/relationships" xmlns:p="http://schemas.openxmlformats.org/presentationml/2006/main">
+  <p:cSld>
+    <p:spTree>
+      <p:nvGrpSpPr>
+        <p:cNvPr id="1" name=""/>
+        <p:cNvGrpSpPr/>
+        <p:nvPr/>
+      </p:nvGrpSpPr>
+      <p:grpSpPr>
+        <a:xfrm>
+          <a:off x="0" y="0"/>
+          <a:ext cx="0" cy="0"/>
+          <a:chOff x="0" y="0"/>
+          <a:chExt cx="0" cy="0"/>
+        </a:xfrm>
+      </p:grpSpPr>
+      <p:sp>
+        <p:nvSpPr>
+          <p:cNvPr id="2" name="Slide Image Placeholder 1"/>
+          <p:cNvSpPr>
+            <a:spLocks noGrp="1" noRot="1" noChangeAspect="1"/>
+          </p:cNvSpPr>
+          <p:nvPr>
+            <p:ph type="sldImg"/>
+          </p:nvPr>
+        </p:nvSpPr>
+        <p:spPr/>
+      </p:sp>
+      <p:sp>
+        <p:nvSpPr>
+          <p:cNvPr id="3" name="Notes Placeholder 2"/>
+          <p:cNvSpPr>
+            <a:spLocks noGrp="1"/>
+          </p:cNvSpPr>
+          <p:nvPr>
+            <p:ph type="body" idx="1"/>
+          </p:nvPr>
+        </p:nvSpPr>
+        <p:spPr/>
+        <p:txBody>
+          <a:bodyPr/>
+          <a:lstStyle/>
+          <a:p>
+            <a:endParaRPr lang="en-US" dirty="0"/>
+          </a:p>
+        </p:txBody>
+      </p:sp>
+      <p:sp>
+        <p:nvSpPr>
+          <p:cNvPr id="4" name="Slide Number Placeholder 3"/>
+          <p:cNvSpPr>
+            <a:spLocks noGrp="1"/>
+          </p:cNvSpPr>
+          <p:nvPr>
+            <p:ph type="sldNum" sz="quarter" idx="5"/>
+          </p:nvPr>
+        </p:nvSpPr>
+        <p:spPr/>
+        <p:txBody>
+          <a:bodyPr/>
+          <a:lstStyle/>
+          <a:p>
+            <a:fld id="{58A32FB6-50F4-4669-AE20-71D0E9BDB9B1}" type="slidenum">
+              <a:rPr lang="en-US" smtClean="0"/>
+              <a:t>13</a:t>
+            </a:fld>
+            <a:endParaRPr lang="en-US"/>
+          </a:p>
+        </p:txBody>
+      </p:sp>
+    </p:spTree>
+    <p:extLst>
+      <p:ext uri="{BB962C8B-B14F-4D97-AF65-F5344CB8AC3E}">
+        <p14:creationId xmlns:p14="http://schemas.microsoft.com/office/powerpoint/2010/main" val="4098844915"/>
+      </p:ext>
+    </p:extLst>
+  </p:cSld>
+  <p:clrMapOvr>
+    <a:masterClrMapping/>
+  </p:clrMapOvr>
+</p:notes>
+</file>
+
+<file path=ppt/notesSlides/notesSlide14.xml><?xml version="1.0" encoding="utf-8"?>
+<p:notes xmlns:a="http://schemas.openxmlformats.org/drawingml/2006/main" xmlns:r="http://schemas.openxmlformats.org/officeDocument/2006/relationships" xmlns:p="http://schemas.openxmlformats.org/presentationml/2006/main">
+  <p:cSld>
+    <p:spTree>
+      <p:nvGrpSpPr>
+        <p:cNvPr id="1" name=""/>
+        <p:cNvGrpSpPr/>
+        <p:nvPr/>
+      </p:nvGrpSpPr>
+      <p:grpSpPr>
+        <a:xfrm>
+          <a:off x="0" y="0"/>
+          <a:ext cx="0" cy="0"/>
+          <a:chOff x="0" y="0"/>
+          <a:chExt cx="0" cy="0"/>
+        </a:xfrm>
+      </p:grpSpPr>
+      <p:sp>
+        <p:nvSpPr>
+          <p:cNvPr id="2" name="Slide Image Placeholder 1"/>
+          <p:cNvSpPr>
+            <a:spLocks noGrp="1" noRot="1" noChangeAspect="1"/>
+          </p:cNvSpPr>
+          <p:nvPr>
+            <p:ph type="sldImg"/>
+          </p:nvPr>
+        </p:nvSpPr>
+        <p:spPr/>
+      </p:sp>
+      <p:sp>
+        <p:nvSpPr>
+          <p:cNvPr id="3" name="Notes Placeholder 2"/>
+          <p:cNvSpPr>
+            <a:spLocks noGrp="1"/>
+          </p:cNvSpPr>
+          <p:nvPr>
+            <p:ph type="body" idx="1"/>
+          </p:nvPr>
+        </p:nvSpPr>
+        <p:spPr/>
+        <p:txBody>
+          <a:bodyPr/>
+          <a:lstStyle/>
+          <a:p>
+            <a:endParaRPr lang="en-US" dirty="0"/>
+          </a:p>
+        </p:txBody>
+      </p:sp>
+      <p:sp>
+        <p:nvSpPr>
+          <p:cNvPr id="4" name="Slide Number Placeholder 3"/>
+          <p:cNvSpPr>
+            <a:spLocks noGrp="1"/>
+          </p:cNvSpPr>
+          <p:nvPr>
+            <p:ph type="sldNum" sz="quarter" idx="5"/>
+          </p:nvPr>
+        </p:nvSpPr>
+        <p:spPr/>
+        <p:txBody>
+          <a:bodyPr/>
+          <a:lstStyle/>
+          <a:p>
+            <a:fld id="{58A32FB6-50F4-4669-AE20-71D0E9BDB9B1}" type="slidenum">
+              <a:rPr lang="en-US" smtClean="0"/>
+              <a:t>14</a:t>
+            </a:fld>
+            <a:endParaRPr lang="en-US"/>
+          </a:p>
+        </p:txBody>
+      </p:sp>
+    </p:spTree>
+    <p:extLst>
+      <p:ext uri="{BB962C8B-B14F-4D97-AF65-F5344CB8AC3E}">
+        <p14:creationId xmlns:p14="http://schemas.microsoft.com/office/powerpoint/2010/main" val="3680954597"/>
+      </p:ext>
+    </p:extLst>
+  </p:cSld>
+  <p:clrMapOvr>
+    <a:masterClrMapping/>
+  </p:clrMapOvr>
+</p:notes>
+</file>
+
+<file path=ppt/notesSlides/notesSlide15.xml><?xml version="1.0" encoding="utf-8"?>
+<p:notes xmlns:a="http://schemas.openxmlformats.org/drawingml/2006/main" xmlns:r="http://schemas.openxmlformats.org/officeDocument/2006/relationships" xmlns:p="http://schemas.openxmlformats.org/presentationml/2006/main">
+  <p:cSld>
+    <p:spTree>
+      <p:nvGrpSpPr>
+        <p:cNvPr id="1" name=""/>
+        <p:cNvGrpSpPr/>
+        <p:nvPr/>
+      </p:nvGrpSpPr>
+      <p:grpSpPr>
+        <a:xfrm>
+          <a:off x="0" y="0"/>
+          <a:ext cx="0" cy="0"/>
+          <a:chOff x="0" y="0"/>
+          <a:chExt cx="0" cy="0"/>
+        </a:xfrm>
+      </p:grpSpPr>
+      <p:sp>
+        <p:nvSpPr>
+          <p:cNvPr id="2" name="Slide Image Placeholder 1"/>
+          <p:cNvSpPr>
+            <a:spLocks noGrp="1" noRot="1" noChangeAspect="1"/>
+          </p:cNvSpPr>
+          <p:nvPr>
+            <p:ph type="sldImg"/>
+          </p:nvPr>
+        </p:nvSpPr>
+        <p:spPr/>
+      </p:sp>
+      <p:sp>
+        <p:nvSpPr>
+          <p:cNvPr id="3" name="Notes Placeholder 2"/>
+          <p:cNvSpPr>
+            <a:spLocks noGrp="1"/>
+          </p:cNvSpPr>
+          <p:nvPr>
+            <p:ph type="body" idx="1"/>
+          </p:nvPr>
+        </p:nvSpPr>
+        <p:spPr/>
+        <p:txBody>
+          <a:bodyPr/>
+          <a:lstStyle/>
+          <a:p>
+            <a:endParaRPr lang="en-US" dirty="0"/>
+          </a:p>
+        </p:txBody>
+      </p:sp>
+      <p:sp>
+        <p:nvSpPr>
+          <p:cNvPr id="4" name="Slide Number Placeholder 3"/>
+          <p:cNvSpPr>
+            <a:spLocks noGrp="1"/>
+          </p:cNvSpPr>
+          <p:nvPr>
+            <p:ph type="sldNum" sz="quarter" idx="5"/>
+          </p:nvPr>
+        </p:nvSpPr>
+        <p:spPr/>
+        <p:txBody>
+          <a:bodyPr/>
+          <a:lstStyle/>
+          <a:p>
+            <a:fld id="{58A32FB6-50F4-4669-AE20-71D0E9BDB9B1}" type="slidenum">
+              <a:rPr lang="en-US" smtClean="0"/>
+              <a:t>15</a:t>
+            </a:fld>
+            <a:endParaRPr lang="en-US"/>
+          </a:p>
+        </p:txBody>
+      </p:sp>
+    </p:spTree>
+    <p:extLst>
+      <p:ext uri="{BB962C8B-B14F-4D97-AF65-F5344CB8AC3E}">
+        <p14:creationId xmlns:p14="http://schemas.microsoft.com/office/powerpoint/2010/main" val="239156178"/>
+      </p:ext>
+    </p:extLst>
+  </p:cSld>
+  <p:clrMapOvr>
+    <a:masterClrMapping/>
+  </p:clrMapOvr>
+</p:notes>
+</file>
+
+<file path=ppt/notesSlides/notesSlide16.xml><?xml version="1.0" encoding="utf-8"?>
+<p:notes xmlns:a="http://schemas.openxmlformats.org/drawingml/2006/main" xmlns:r="http://schemas.openxmlformats.org/officeDocument/2006/relationships" xmlns:p="http://schemas.openxmlformats.org/presentationml/2006/main">
+  <p:cSld>
+    <p:spTree>
+      <p:nvGrpSpPr>
+        <p:cNvPr id="1" name=""/>
+        <p:cNvGrpSpPr/>
+        <p:nvPr/>
+      </p:nvGrpSpPr>
+      <p:grpSpPr>
+        <a:xfrm>
+          <a:off x="0" y="0"/>
+          <a:ext cx="0" cy="0"/>
+          <a:chOff x="0" y="0"/>
+          <a:chExt cx="0" cy="0"/>
+        </a:xfrm>
+      </p:grpSpPr>
+      <p:sp>
+        <p:nvSpPr>
+          <p:cNvPr id="2" name="Slide Image Placeholder 1"/>
+          <p:cNvSpPr>
+            <a:spLocks noGrp="1" noRot="1" noChangeAspect="1"/>
+          </p:cNvSpPr>
+          <p:nvPr>
+            <p:ph type="sldImg"/>
+          </p:nvPr>
+        </p:nvSpPr>
+        <p:spPr/>
+        <p:txBody>
+          <a:bodyPr/>
+          <a:lstStyle/>
+          <a:p>
+            <a:endParaRPr lang="en-US"/>
+          </a:p>
+        </p:txBody>
+      </p:sp>
+      <p:sp>
+        <p:nvSpPr>
+          <p:cNvPr id="3" name="Notes Placeholder 2"/>
+          <p:cNvSpPr>
+            <a:spLocks noGrp="1"/>
+          </p:cNvSpPr>
+          <p:nvPr>
+            <p:ph type="body" idx="1"/>
+          </p:nvPr>
+        </p:nvSpPr>
+        <p:spPr/>
+        <p:txBody>
+          <a:bodyPr/>
+          <a:lstStyle/>
+          <a:p>
+            <a:endParaRPr lang="en-US" dirty="0"/>
+          </a:p>
+        </p:txBody>
+      </p:sp>
+      <p:sp>
+        <p:nvSpPr>
+          <p:cNvPr id="4" name="Slide Number Placeholder 3"/>
+          <p:cNvSpPr>
+            <a:spLocks noGrp="1"/>
+          </p:cNvSpPr>
+          <p:nvPr>
+            <p:ph type="sldNum" sz="quarter" idx="5"/>
+          </p:nvPr>
+        </p:nvSpPr>
+        <p:spPr/>
+        <p:txBody>
+          <a:bodyPr/>
+          <a:lstStyle/>
+          <a:p>
+            <a:fld id="{58A32FB6-50F4-4669-AE20-71D0E9BDB9B1}" type="slidenum">
+              <a:rPr lang="en-US" smtClean="0"/>
               <a:t>16</a:t>
             </a:fld>
             <a:endParaRPr lang="en-US"/>
@@ -665,6 +1191,174 @@
     <p:extLst>
       <p:ext uri="{BB962C8B-B14F-4D97-AF65-F5344CB8AC3E}">
         <p14:creationId xmlns:p14="http://schemas.microsoft.com/office/powerpoint/2010/main" val="1124451925"/>
+      </p:ext>
+    </p:extLst>
+  </p:cSld>
+  <p:clrMapOvr>
+    <a:masterClrMapping/>
+  </p:clrMapOvr>
+</p:notes>
+</file>
+
+<file path=ppt/notesSlides/notesSlide17.xml><?xml version="1.0" encoding="utf-8"?>
+<p:notes xmlns:a="http://schemas.openxmlformats.org/drawingml/2006/main" xmlns:r="http://schemas.openxmlformats.org/officeDocument/2006/relationships" xmlns:p="http://schemas.openxmlformats.org/presentationml/2006/main">
+  <p:cSld>
+    <p:spTree>
+      <p:nvGrpSpPr>
+        <p:cNvPr id="1" name=""/>
+        <p:cNvGrpSpPr/>
+        <p:nvPr/>
+      </p:nvGrpSpPr>
+      <p:grpSpPr>
+        <a:xfrm>
+          <a:off x="0" y="0"/>
+          <a:ext cx="0" cy="0"/>
+          <a:chOff x="0" y="0"/>
+          <a:chExt cx="0" cy="0"/>
+        </a:xfrm>
+      </p:grpSpPr>
+      <p:sp>
+        <p:nvSpPr>
+          <p:cNvPr id="2" name="Slide Image Placeholder 1"/>
+          <p:cNvSpPr>
+            <a:spLocks noGrp="1" noRot="1" noChangeAspect="1"/>
+          </p:cNvSpPr>
+          <p:nvPr>
+            <p:ph type="sldImg"/>
+          </p:nvPr>
+        </p:nvSpPr>
+        <p:spPr/>
+      </p:sp>
+      <p:sp>
+        <p:nvSpPr>
+          <p:cNvPr id="3" name="Notes Placeholder 2"/>
+          <p:cNvSpPr>
+            <a:spLocks noGrp="1"/>
+          </p:cNvSpPr>
+          <p:nvPr>
+            <p:ph type="body" idx="1"/>
+          </p:nvPr>
+        </p:nvSpPr>
+        <p:spPr/>
+        <p:txBody>
+          <a:bodyPr/>
+          <a:lstStyle/>
+          <a:p>
+            <a:endParaRPr lang="en-US" dirty="0"/>
+          </a:p>
+        </p:txBody>
+      </p:sp>
+      <p:sp>
+        <p:nvSpPr>
+          <p:cNvPr id="4" name="Slide Number Placeholder 3"/>
+          <p:cNvSpPr>
+            <a:spLocks noGrp="1"/>
+          </p:cNvSpPr>
+          <p:nvPr>
+            <p:ph type="sldNum" sz="quarter" idx="5"/>
+          </p:nvPr>
+        </p:nvSpPr>
+        <p:spPr/>
+        <p:txBody>
+          <a:bodyPr/>
+          <a:lstStyle/>
+          <a:p>
+            <a:fld id="{58A32FB6-50F4-4669-AE20-71D0E9BDB9B1}" type="slidenum">
+              <a:rPr lang="en-US" smtClean="0"/>
+              <a:t>17</a:t>
+            </a:fld>
+            <a:endParaRPr lang="en-US"/>
+          </a:p>
+        </p:txBody>
+      </p:sp>
+    </p:spTree>
+    <p:extLst>
+      <p:ext uri="{BB962C8B-B14F-4D97-AF65-F5344CB8AC3E}">
+        <p14:creationId xmlns:p14="http://schemas.microsoft.com/office/powerpoint/2010/main" val="874235954"/>
+      </p:ext>
+    </p:extLst>
+  </p:cSld>
+  <p:clrMapOvr>
+    <a:masterClrMapping/>
+  </p:clrMapOvr>
+</p:notes>
+</file>
+
+<file path=ppt/notesSlides/notesSlide18.xml><?xml version="1.0" encoding="utf-8"?>
+<p:notes xmlns:a="http://schemas.openxmlformats.org/drawingml/2006/main" xmlns:r="http://schemas.openxmlformats.org/officeDocument/2006/relationships" xmlns:p="http://schemas.openxmlformats.org/presentationml/2006/main">
+  <p:cSld>
+    <p:spTree>
+      <p:nvGrpSpPr>
+        <p:cNvPr id="1" name=""/>
+        <p:cNvGrpSpPr/>
+        <p:nvPr/>
+      </p:nvGrpSpPr>
+      <p:grpSpPr>
+        <a:xfrm>
+          <a:off x="0" y="0"/>
+          <a:ext cx="0" cy="0"/>
+          <a:chOff x="0" y="0"/>
+          <a:chExt cx="0" cy="0"/>
+        </a:xfrm>
+      </p:grpSpPr>
+      <p:sp>
+        <p:nvSpPr>
+          <p:cNvPr id="2" name="Slide Image Placeholder 1"/>
+          <p:cNvSpPr>
+            <a:spLocks noGrp="1" noRot="1" noChangeAspect="1"/>
+          </p:cNvSpPr>
+          <p:nvPr>
+            <p:ph type="sldImg"/>
+          </p:nvPr>
+        </p:nvSpPr>
+        <p:spPr/>
+      </p:sp>
+      <p:sp>
+        <p:nvSpPr>
+          <p:cNvPr id="3" name="Notes Placeholder 2"/>
+          <p:cNvSpPr>
+            <a:spLocks noGrp="1"/>
+          </p:cNvSpPr>
+          <p:nvPr>
+            <p:ph type="body" idx="1"/>
+          </p:nvPr>
+        </p:nvSpPr>
+        <p:spPr/>
+        <p:txBody>
+          <a:bodyPr/>
+          <a:lstStyle/>
+          <a:p>
+            <a:endParaRPr lang="en-US" dirty="0"/>
+          </a:p>
+        </p:txBody>
+      </p:sp>
+      <p:sp>
+        <p:nvSpPr>
+          <p:cNvPr id="4" name="Slide Number Placeholder 3"/>
+          <p:cNvSpPr>
+            <a:spLocks noGrp="1"/>
+          </p:cNvSpPr>
+          <p:nvPr>
+            <p:ph type="sldNum" sz="quarter" idx="5"/>
+          </p:nvPr>
+        </p:nvSpPr>
+        <p:spPr/>
+        <p:txBody>
+          <a:bodyPr/>
+          <a:lstStyle/>
+          <a:p>
+            <a:fld id="{58A32FB6-50F4-4669-AE20-71D0E9BDB9B1}" type="slidenum">
+              <a:rPr lang="en-US" smtClean="0"/>
+              <a:t>18</a:t>
+            </a:fld>
+            <a:endParaRPr lang="en-US"/>
+          </a:p>
+        </p:txBody>
+      </p:sp>
+    </p:spTree>
+    <p:extLst>
+      <p:ext uri="{BB962C8B-B14F-4D97-AF65-F5344CB8AC3E}">
+        <p14:creationId xmlns:p14="http://schemas.microsoft.com/office/powerpoint/2010/main" val="2315270927"/>
       </p:ext>
     </p:extLst>
   </p:cSld>
@@ -702,13 +1396,6 @@
           </p:nvPr>
         </p:nvSpPr>
         <p:spPr/>
-        <p:txBody>
-          <a:bodyPr/>
-          <a:lstStyle/>
-          <a:p>
-            <a:endParaRPr lang="en-US"/>
-          </a:p>
-        </p:txBody>
       </p:sp>
       <p:sp>
         <p:nvSpPr>
@@ -725,7 +1412,15 @@
           <a:bodyPr/>
           <a:lstStyle/>
           <a:p>
-            <a:endParaRPr lang="en-US" dirty="0"/>
+            <a:endParaRPr lang="en-US" sz="1200" kern="1200" dirty="0">
+              <a:solidFill>
+                <a:schemeClr val="tx1"/>
+              </a:solidFill>
+              <a:effectLst/>
+              <a:latin typeface="+mn-lt"/>
+              <a:ea typeface="+mn-ea"/>
+              <a:cs typeface="+mn-cs"/>
+            </a:endParaRPr>
           </a:p>
         </p:txBody>
       </p:sp>
@@ -746,7 +1441,7 @@
           <a:p>
             <a:fld id="{58A32FB6-50F4-4669-AE20-71D0E9BDB9B1}" type="slidenum">
               <a:rPr lang="en-US" smtClean="0"/>
-              <a:t>5</a:t>
+              <a:t>2</a:t>
             </a:fld>
             <a:endParaRPr lang="en-US"/>
           </a:p>
@@ -755,7 +1450,7 @@
     </p:spTree>
     <p:extLst>
       <p:ext uri="{BB962C8B-B14F-4D97-AF65-F5344CB8AC3E}">
-        <p14:creationId xmlns:p14="http://schemas.microsoft.com/office/powerpoint/2010/main" val="931075389"/>
+        <p14:creationId xmlns:p14="http://schemas.microsoft.com/office/powerpoint/2010/main" val="2347787555"/>
       </p:ext>
     </p:extLst>
   </p:cSld>
@@ -770,13 +1465,7 @@
   <p:cSld>
     <p:spTree>
       <p:nvGrpSpPr>
-        <p:cNvPr id="1" name="">
-          <a:extLst>
-            <a:ext uri="{FF2B5EF4-FFF2-40B4-BE49-F238E27FC236}">
-              <a16:creationId xmlns:a16="http://schemas.microsoft.com/office/drawing/2014/main" id="{D56E3D88-B7EF-3419-53E0-F5F034E32DF9}"/>
-            </a:ext>
-          </a:extLst>
-        </p:cNvPr>
+        <p:cNvPr id="1" name=""/>
         <p:cNvGrpSpPr/>
         <p:nvPr/>
       </p:nvGrpSpPr>
@@ -790,13 +1479,7 @@
       </p:grpSpPr>
       <p:sp>
         <p:nvSpPr>
-          <p:cNvPr id="2" name="Slide Image Placeholder 1">
-            <a:extLst>
-              <a:ext uri="{FF2B5EF4-FFF2-40B4-BE49-F238E27FC236}">
-                <a16:creationId xmlns:a16="http://schemas.microsoft.com/office/drawing/2014/main" id="{499A2C0D-0A6D-3FB7-A33F-6DB45148B3F5}"/>
-              </a:ext>
-            </a:extLst>
-          </p:cNvPr>
+          <p:cNvPr id="2" name="Slide Image Placeholder 1"/>
           <p:cNvSpPr>
             <a:spLocks noGrp="1" noRot="1" noChangeAspect="1"/>
           </p:cNvSpPr>
@@ -805,23 +1488,10 @@
           </p:nvPr>
         </p:nvSpPr>
         <p:spPr/>
-        <p:txBody>
-          <a:bodyPr/>
-          <a:lstStyle/>
-          <a:p>
-            <a:endParaRPr lang="en-US"/>
-          </a:p>
-        </p:txBody>
-      </p:sp>
-      <p:sp>
-        <p:nvSpPr>
-          <p:cNvPr id="3" name="Notes Placeholder 2">
-            <a:extLst>
-              <a:ext uri="{FF2B5EF4-FFF2-40B4-BE49-F238E27FC236}">
-                <a16:creationId xmlns:a16="http://schemas.microsoft.com/office/drawing/2014/main" id="{014C59A5-9A08-C08E-3AD8-363E4AA71E42}"/>
-              </a:ext>
-            </a:extLst>
-          </p:cNvPr>
+      </p:sp>
+      <p:sp>
+        <p:nvSpPr>
+          <p:cNvPr id="3" name="Notes Placeholder 2"/>
           <p:cNvSpPr>
             <a:spLocks noGrp="1"/>
           </p:cNvSpPr>
@@ -840,13 +1510,7 @@
       </p:sp>
       <p:sp>
         <p:nvSpPr>
-          <p:cNvPr id="4" name="Slide Number Placeholder 3">
-            <a:extLst>
-              <a:ext uri="{FF2B5EF4-FFF2-40B4-BE49-F238E27FC236}">
-                <a16:creationId xmlns:a16="http://schemas.microsoft.com/office/drawing/2014/main" id="{028F1139-D793-3594-4057-CC3B5485A8C8}"/>
-              </a:ext>
-            </a:extLst>
-          </p:cNvPr>
+          <p:cNvPr id="4" name="Slide Number Placeholder 3"/>
           <p:cNvSpPr>
             <a:spLocks noGrp="1"/>
           </p:cNvSpPr>
@@ -861,7 +1525,7 @@
           <a:p>
             <a:fld id="{58A32FB6-50F4-4669-AE20-71D0E9BDB9B1}" type="slidenum">
               <a:rPr lang="en-US" smtClean="0"/>
-              <a:t>6</a:t>
+              <a:t>3</a:t>
             </a:fld>
             <a:endParaRPr lang="en-US"/>
           </a:p>
@@ -870,7 +1534,7 @@
     </p:spTree>
     <p:extLst>
       <p:ext uri="{BB962C8B-B14F-4D97-AF65-F5344CB8AC3E}">
-        <p14:creationId xmlns:p14="http://schemas.microsoft.com/office/powerpoint/2010/main" val="1959026381"/>
+        <p14:creationId xmlns:p14="http://schemas.microsoft.com/office/powerpoint/2010/main" val="3537740505"/>
       </p:ext>
     </p:extLst>
   </p:cSld>
@@ -885,13 +1549,7 @@
   <p:cSld>
     <p:spTree>
       <p:nvGrpSpPr>
-        <p:cNvPr id="1" name="">
-          <a:extLst>
-            <a:ext uri="{FF2B5EF4-FFF2-40B4-BE49-F238E27FC236}">
-              <a16:creationId xmlns:a16="http://schemas.microsoft.com/office/drawing/2014/main" id="{4DE6D9FA-7EAC-ACF3-D583-4FE99D586561}"/>
-            </a:ext>
-          </a:extLst>
-        </p:cNvPr>
+        <p:cNvPr id="1" name=""/>
         <p:cNvGrpSpPr/>
         <p:nvPr/>
       </p:nvGrpSpPr>
@@ -905,13 +1563,7 @@
       </p:grpSpPr>
       <p:sp>
         <p:nvSpPr>
-          <p:cNvPr id="2" name="Slide Image Placeholder 1">
-            <a:extLst>
-              <a:ext uri="{FF2B5EF4-FFF2-40B4-BE49-F238E27FC236}">
-                <a16:creationId xmlns:a16="http://schemas.microsoft.com/office/drawing/2014/main" id="{6F8A3174-F659-27AF-F559-EEE3AA578CDC}"/>
-              </a:ext>
-            </a:extLst>
-          </p:cNvPr>
+          <p:cNvPr id="2" name="Slide Image Placeholder 1"/>
           <p:cNvSpPr>
             <a:spLocks noGrp="1" noRot="1" noChangeAspect="1"/>
           </p:cNvSpPr>
@@ -920,23 +1572,10 @@
           </p:nvPr>
         </p:nvSpPr>
         <p:spPr/>
-        <p:txBody>
-          <a:bodyPr/>
-          <a:lstStyle/>
-          <a:p>
-            <a:endParaRPr lang="en-US"/>
-          </a:p>
-        </p:txBody>
-      </p:sp>
-      <p:sp>
-        <p:nvSpPr>
-          <p:cNvPr id="3" name="Notes Placeholder 2">
-            <a:extLst>
-              <a:ext uri="{FF2B5EF4-FFF2-40B4-BE49-F238E27FC236}">
-                <a16:creationId xmlns:a16="http://schemas.microsoft.com/office/drawing/2014/main" id="{79728C87-50E2-877A-79E0-3350475BF864}"/>
-              </a:ext>
-            </a:extLst>
-          </p:cNvPr>
+      </p:sp>
+      <p:sp>
+        <p:nvSpPr>
+          <p:cNvPr id="3" name="Notes Placeholder 2"/>
           <p:cNvSpPr>
             <a:spLocks noGrp="1"/>
           </p:cNvSpPr>
@@ -955,13 +1594,7 @@
       </p:sp>
       <p:sp>
         <p:nvSpPr>
-          <p:cNvPr id="4" name="Slide Number Placeholder 3">
-            <a:extLst>
-              <a:ext uri="{FF2B5EF4-FFF2-40B4-BE49-F238E27FC236}">
-                <a16:creationId xmlns:a16="http://schemas.microsoft.com/office/drawing/2014/main" id="{8FE48EFF-2FE1-22AA-6567-98618F7B964E}"/>
-              </a:ext>
-            </a:extLst>
-          </p:cNvPr>
+          <p:cNvPr id="4" name="Slide Number Placeholder 3"/>
           <p:cNvSpPr>
             <a:spLocks noGrp="1"/>
           </p:cNvSpPr>
@@ -976,7 +1609,7 @@
           <a:p>
             <a:fld id="{58A32FB6-50F4-4669-AE20-71D0E9BDB9B1}" type="slidenum">
               <a:rPr lang="en-US" smtClean="0"/>
-              <a:t>7</a:t>
+              <a:t>4</a:t>
             </a:fld>
             <a:endParaRPr lang="en-US"/>
           </a:p>
@@ -985,7 +1618,7 @@
     </p:spTree>
     <p:extLst>
       <p:ext uri="{BB962C8B-B14F-4D97-AF65-F5344CB8AC3E}">
-        <p14:creationId xmlns:p14="http://schemas.microsoft.com/office/powerpoint/2010/main" val="1159106697"/>
+        <p14:creationId xmlns:p14="http://schemas.microsoft.com/office/powerpoint/2010/main" val="2218365953"/>
       </p:ext>
     </p:extLst>
   </p:cSld>
@@ -1067,7 +1700,7 @@
           <a:p>
             <a:fld id="{58A32FB6-50F4-4669-AE20-71D0E9BDB9B1}" type="slidenum">
               <a:rPr lang="en-US" smtClean="0"/>
-              <a:t>8</a:t>
+              <a:t>5</a:t>
             </a:fld>
             <a:endParaRPr lang="en-US"/>
           </a:p>
@@ -1076,7 +1709,7 @@
     </p:spTree>
     <p:extLst>
       <p:ext uri="{BB962C8B-B14F-4D97-AF65-F5344CB8AC3E}">
-        <p14:creationId xmlns:p14="http://schemas.microsoft.com/office/powerpoint/2010/main" val="3154613933"/>
+        <p14:creationId xmlns:p14="http://schemas.microsoft.com/office/powerpoint/2010/main" val="931075389"/>
       </p:ext>
     </p:extLst>
   </p:cSld>
@@ -1094,7 +1727,7 @@
         <p:cNvPr id="1" name="">
           <a:extLst>
             <a:ext uri="{FF2B5EF4-FFF2-40B4-BE49-F238E27FC236}">
-              <a16:creationId xmlns:a16="http://schemas.microsoft.com/office/drawing/2014/main" id="{B502DF96-A1FF-CCF2-D39E-0DF1B095F296}"/>
+              <a16:creationId xmlns:a16="http://schemas.microsoft.com/office/drawing/2014/main" id="{D56E3D88-B7EF-3419-53E0-F5F034E32DF9}"/>
             </a:ext>
           </a:extLst>
         </p:cNvPr>
@@ -1114,7 +1747,7 @@
           <p:cNvPr id="2" name="Slide Image Placeholder 1">
             <a:extLst>
               <a:ext uri="{FF2B5EF4-FFF2-40B4-BE49-F238E27FC236}">
-                <a16:creationId xmlns:a16="http://schemas.microsoft.com/office/drawing/2014/main" id="{24ABD3FE-8DD1-6198-B5DF-3EEA8E8EF0D4}"/>
+                <a16:creationId xmlns:a16="http://schemas.microsoft.com/office/drawing/2014/main" id="{499A2C0D-0A6D-3FB7-A33F-6DB45148B3F5}"/>
               </a:ext>
             </a:extLst>
           </p:cNvPr>
@@ -1139,7 +1772,7 @@
           <p:cNvPr id="3" name="Notes Placeholder 2">
             <a:extLst>
               <a:ext uri="{FF2B5EF4-FFF2-40B4-BE49-F238E27FC236}">
-                <a16:creationId xmlns:a16="http://schemas.microsoft.com/office/drawing/2014/main" id="{47BE3C09-0879-0185-A701-F08D7D6EB841}"/>
+                <a16:creationId xmlns:a16="http://schemas.microsoft.com/office/drawing/2014/main" id="{014C59A5-9A08-C08E-3AD8-363E4AA71E42}"/>
               </a:ext>
             </a:extLst>
           </p:cNvPr>
@@ -1164,7 +1797,7 @@
           <p:cNvPr id="4" name="Slide Number Placeholder 3">
             <a:extLst>
               <a:ext uri="{FF2B5EF4-FFF2-40B4-BE49-F238E27FC236}">
-                <a16:creationId xmlns:a16="http://schemas.microsoft.com/office/drawing/2014/main" id="{2A2DBDAA-C66D-E24C-4148-2F1BE747EC2C}"/>
+                <a16:creationId xmlns:a16="http://schemas.microsoft.com/office/drawing/2014/main" id="{028F1139-D793-3594-4057-CC3B5485A8C8}"/>
               </a:ext>
             </a:extLst>
           </p:cNvPr>
@@ -1182,7 +1815,7 @@
           <a:p>
             <a:fld id="{58A32FB6-50F4-4669-AE20-71D0E9BDB9B1}" type="slidenum">
               <a:rPr lang="en-US" smtClean="0"/>
-              <a:t>9</a:t>
+              <a:t>6</a:t>
             </a:fld>
             <a:endParaRPr lang="en-US"/>
           </a:p>
@@ -1191,7 +1824,7 @@
     </p:spTree>
     <p:extLst>
       <p:ext uri="{BB962C8B-B14F-4D97-AF65-F5344CB8AC3E}">
-        <p14:creationId xmlns:p14="http://schemas.microsoft.com/office/powerpoint/2010/main" val="2127472776"/>
+        <p14:creationId xmlns:p14="http://schemas.microsoft.com/office/powerpoint/2010/main" val="1959026381"/>
       </p:ext>
     </p:extLst>
   </p:cSld>
@@ -1206,7 +1839,13 @@
   <p:cSld>
     <p:spTree>
       <p:nvGrpSpPr>
-        <p:cNvPr id="1" name=""/>
+        <p:cNvPr id="1" name="">
+          <a:extLst>
+            <a:ext uri="{FF2B5EF4-FFF2-40B4-BE49-F238E27FC236}">
+              <a16:creationId xmlns:a16="http://schemas.microsoft.com/office/drawing/2014/main" id="{4DE6D9FA-7EAC-ACF3-D583-4FE99D586561}"/>
+            </a:ext>
+          </a:extLst>
+        </p:cNvPr>
         <p:cNvGrpSpPr/>
         <p:nvPr/>
       </p:nvGrpSpPr>
@@ -1220,7 +1859,13 @@
       </p:grpSpPr>
       <p:sp>
         <p:nvSpPr>
-          <p:cNvPr id="2" name="Slide Image Placeholder 1"/>
+          <p:cNvPr id="2" name="Slide Image Placeholder 1">
+            <a:extLst>
+              <a:ext uri="{FF2B5EF4-FFF2-40B4-BE49-F238E27FC236}">
+                <a16:creationId xmlns:a16="http://schemas.microsoft.com/office/drawing/2014/main" id="{6F8A3174-F659-27AF-F559-EEE3AA578CDC}"/>
+              </a:ext>
+            </a:extLst>
+          </p:cNvPr>
           <p:cNvSpPr>
             <a:spLocks noGrp="1" noRot="1" noChangeAspect="1"/>
           </p:cNvSpPr>
@@ -1229,10 +1874,23 @@
           </p:nvPr>
         </p:nvSpPr>
         <p:spPr/>
-      </p:sp>
-      <p:sp>
-        <p:nvSpPr>
-          <p:cNvPr id="3" name="Notes Placeholder 2"/>
+        <p:txBody>
+          <a:bodyPr/>
+          <a:lstStyle/>
+          <a:p>
+            <a:endParaRPr lang="en-US"/>
+          </a:p>
+        </p:txBody>
+      </p:sp>
+      <p:sp>
+        <p:nvSpPr>
+          <p:cNvPr id="3" name="Notes Placeholder 2">
+            <a:extLst>
+              <a:ext uri="{FF2B5EF4-FFF2-40B4-BE49-F238E27FC236}">
+                <a16:creationId xmlns:a16="http://schemas.microsoft.com/office/drawing/2014/main" id="{79728C87-50E2-877A-79E0-3350475BF864}"/>
+              </a:ext>
+            </a:extLst>
+          </p:cNvPr>
           <p:cNvSpPr>
             <a:spLocks noGrp="1"/>
           </p:cNvSpPr>
@@ -1251,7 +1909,13 @@
       </p:sp>
       <p:sp>
         <p:nvSpPr>
-          <p:cNvPr id="4" name="Slide Number Placeholder 3"/>
+          <p:cNvPr id="4" name="Slide Number Placeholder 3">
+            <a:extLst>
+              <a:ext uri="{FF2B5EF4-FFF2-40B4-BE49-F238E27FC236}">
+                <a16:creationId xmlns:a16="http://schemas.microsoft.com/office/drawing/2014/main" id="{8FE48EFF-2FE1-22AA-6567-98618F7B964E}"/>
+              </a:ext>
+            </a:extLst>
+          </p:cNvPr>
           <p:cNvSpPr>
             <a:spLocks noGrp="1"/>
           </p:cNvSpPr>
@@ -1266,7 +1930,7 @@
           <a:p>
             <a:fld id="{58A32FB6-50F4-4669-AE20-71D0E9BDB9B1}" type="slidenum">
               <a:rPr lang="en-US" smtClean="0"/>
-              <a:t>10</a:t>
+              <a:t>7</a:t>
             </a:fld>
             <a:endParaRPr lang="en-US"/>
           </a:p>
@@ -1275,7 +1939,7 @@
     </p:spTree>
     <p:extLst>
       <p:ext uri="{BB962C8B-B14F-4D97-AF65-F5344CB8AC3E}">
-        <p14:creationId xmlns:p14="http://schemas.microsoft.com/office/powerpoint/2010/main" val="3875492319"/>
+        <p14:creationId xmlns:p14="http://schemas.microsoft.com/office/powerpoint/2010/main" val="1159106697"/>
       </p:ext>
     </p:extLst>
   </p:cSld>
@@ -1336,10 +2000,6 @@
           <a:bodyPr/>
           <a:lstStyle/>
           <a:p>
-            <a:r>
-              <a:rPr lang="en-US" dirty="0" err="1"/>
-              <a:t>drfdxrcfgtvgt</a:t>
-            </a:r>
             <a:endParaRPr lang="en-US" dirty="0"/>
           </a:p>
         </p:txBody>
@@ -1361,7 +2021,7 @@
           <a:p>
             <a:fld id="{58A32FB6-50F4-4669-AE20-71D0E9BDB9B1}" type="slidenum">
               <a:rPr lang="en-US" smtClean="0"/>
-              <a:t>11</a:t>
+              <a:t>8</a:t>
             </a:fld>
             <a:endParaRPr lang="en-US"/>
           </a:p>
@@ -1370,7 +2030,7 @@
     </p:spTree>
     <p:extLst>
       <p:ext uri="{BB962C8B-B14F-4D97-AF65-F5344CB8AC3E}">
-        <p14:creationId xmlns:p14="http://schemas.microsoft.com/office/powerpoint/2010/main" val="98056021"/>
+        <p14:creationId xmlns:p14="http://schemas.microsoft.com/office/powerpoint/2010/main" val="3154613933"/>
       </p:ext>
     </p:extLst>
   </p:cSld>
@@ -1385,7 +2045,13 @@
   <p:cSld>
     <p:spTree>
       <p:nvGrpSpPr>
-        <p:cNvPr id="1" name=""/>
+        <p:cNvPr id="1" name="">
+          <a:extLst>
+            <a:ext uri="{FF2B5EF4-FFF2-40B4-BE49-F238E27FC236}">
+              <a16:creationId xmlns:a16="http://schemas.microsoft.com/office/drawing/2014/main" id="{B502DF96-A1FF-CCF2-D39E-0DF1B095F296}"/>
+            </a:ext>
+          </a:extLst>
+        </p:cNvPr>
         <p:cNvGrpSpPr/>
         <p:nvPr/>
       </p:nvGrpSpPr>
@@ -1399,7 +2065,13 @@
       </p:grpSpPr>
       <p:sp>
         <p:nvSpPr>
-          <p:cNvPr id="2" name="Slide Image Placeholder 1"/>
+          <p:cNvPr id="2" name="Slide Image Placeholder 1">
+            <a:extLst>
+              <a:ext uri="{FF2B5EF4-FFF2-40B4-BE49-F238E27FC236}">
+                <a16:creationId xmlns:a16="http://schemas.microsoft.com/office/drawing/2014/main" id="{24ABD3FE-8DD1-6198-B5DF-3EEA8E8EF0D4}"/>
+              </a:ext>
+            </a:extLst>
+          </p:cNvPr>
           <p:cNvSpPr>
             <a:spLocks noGrp="1" noRot="1" noChangeAspect="1"/>
           </p:cNvSpPr>
@@ -1418,7 +2090,13 @@
       </p:sp>
       <p:sp>
         <p:nvSpPr>
-          <p:cNvPr id="3" name="Notes Placeholder 2"/>
+          <p:cNvPr id="3" name="Notes Placeholder 2">
+            <a:extLst>
+              <a:ext uri="{FF2B5EF4-FFF2-40B4-BE49-F238E27FC236}">
+                <a16:creationId xmlns:a16="http://schemas.microsoft.com/office/drawing/2014/main" id="{47BE3C09-0879-0185-A701-F08D7D6EB841}"/>
+              </a:ext>
+            </a:extLst>
+          </p:cNvPr>
           <p:cNvSpPr>
             <a:spLocks noGrp="1"/>
           </p:cNvSpPr>
@@ -1437,7 +2115,13 @@
       </p:sp>
       <p:sp>
         <p:nvSpPr>
-          <p:cNvPr id="4" name="Slide Number Placeholder 3"/>
+          <p:cNvPr id="4" name="Slide Number Placeholder 3">
+            <a:extLst>
+              <a:ext uri="{FF2B5EF4-FFF2-40B4-BE49-F238E27FC236}">
+                <a16:creationId xmlns:a16="http://schemas.microsoft.com/office/drawing/2014/main" id="{2A2DBDAA-C66D-E24C-4148-2F1BE747EC2C}"/>
+              </a:ext>
+            </a:extLst>
+          </p:cNvPr>
           <p:cNvSpPr>
             <a:spLocks noGrp="1"/>
           </p:cNvSpPr>
@@ -1452,7 +2136,7 @@
           <a:p>
             <a:fld id="{58A32FB6-50F4-4669-AE20-71D0E9BDB9B1}" type="slidenum">
               <a:rPr lang="en-US" smtClean="0"/>
-              <a:t>12</a:t>
+              <a:t>9</a:t>
             </a:fld>
             <a:endParaRPr lang="en-US"/>
           </a:p>
@@ -1461,7 +2145,7 @@
     </p:spTree>
     <p:extLst>
       <p:ext uri="{BB962C8B-B14F-4D97-AF65-F5344CB8AC3E}">
-        <p14:creationId xmlns:p14="http://schemas.microsoft.com/office/powerpoint/2010/main" val="1344464461"/>
+        <p14:creationId xmlns:p14="http://schemas.microsoft.com/office/powerpoint/2010/main" val="2127472776"/>
       </p:ext>
     </p:extLst>
   </p:cSld>
@@ -1650,7 +2334,7 @@
           <a:p>
             <a:fld id="{5BCAD085-E8A6-8845-BD4E-CB4CCA059FC4}" type="datetimeFigureOut">
               <a:rPr lang="en-US" smtClean="0"/>
-              <a:t>4/8/2026</a:t>
+              <a:t>4/9/2026</a:t>
             </a:fld>
             <a:endParaRPr lang="en-US"/>
           </a:p>
@@ -1818,7 +2502,7 @@
           <a:p>
             <a:fld id="{5BCAD085-E8A6-8845-BD4E-CB4CCA059FC4}" type="datetimeFigureOut">
               <a:rPr lang="en-US" smtClean="0"/>
-              <a:t>4/8/2026</a:t>
+              <a:t>4/9/2026</a:t>
             </a:fld>
             <a:endParaRPr lang="en-US"/>
           </a:p>
@@ -1996,7 +2680,7 @@
           <a:p>
             <a:fld id="{5BCAD085-E8A6-8845-BD4E-CB4CCA059FC4}" type="datetimeFigureOut">
               <a:rPr lang="en-US" smtClean="0"/>
-              <a:t>4/8/2026</a:t>
+              <a:t>4/9/2026</a:t>
             </a:fld>
             <a:endParaRPr lang="en-US"/>
           </a:p>
@@ -2164,7 +2848,7 @@
           <a:p>
             <a:fld id="{5BCAD085-E8A6-8845-BD4E-CB4CCA059FC4}" type="datetimeFigureOut">
               <a:rPr lang="en-US" smtClean="0"/>
-              <a:t>4/8/2026</a:t>
+              <a:t>4/9/2026</a:t>
             </a:fld>
             <a:endParaRPr lang="en-US"/>
           </a:p>
@@ -2409,7 +3093,7 @@
           <a:p>
             <a:fld id="{5BCAD085-E8A6-8845-BD4E-CB4CCA059FC4}" type="datetimeFigureOut">
               <a:rPr lang="en-US" smtClean="0"/>
-              <a:t>4/8/2026</a:t>
+              <a:t>4/9/2026</a:t>
             </a:fld>
             <a:endParaRPr lang="en-US"/>
           </a:p>
@@ -2694,7 +3378,7 @@
           <a:p>
             <a:fld id="{5BCAD085-E8A6-8845-BD4E-CB4CCA059FC4}" type="datetimeFigureOut">
               <a:rPr lang="en-US" smtClean="0"/>
-              <a:t>4/8/2026</a:t>
+              <a:t>4/9/2026</a:t>
             </a:fld>
             <a:endParaRPr lang="en-US"/>
           </a:p>
@@ -3113,7 +3797,7 @@
           <a:p>
             <a:fld id="{5BCAD085-E8A6-8845-BD4E-CB4CCA059FC4}" type="datetimeFigureOut">
               <a:rPr lang="en-US" smtClean="0"/>
-              <a:t>4/8/2026</a:t>
+              <a:t>4/9/2026</a:t>
             </a:fld>
             <a:endParaRPr lang="en-US"/>
           </a:p>
@@ -3230,7 +3914,7 @@
           <a:p>
             <a:fld id="{5BCAD085-E8A6-8845-BD4E-CB4CCA059FC4}" type="datetimeFigureOut">
               <a:rPr lang="en-US" smtClean="0"/>
-              <a:t>4/8/2026</a:t>
+              <a:t>4/9/2026</a:t>
             </a:fld>
             <a:endParaRPr lang="en-US"/>
           </a:p>
@@ -3325,7 +4009,7 @@
           <a:p>
             <a:fld id="{5BCAD085-E8A6-8845-BD4E-CB4CCA059FC4}" type="datetimeFigureOut">
               <a:rPr lang="en-US" smtClean="0"/>
-              <a:t>4/8/2026</a:t>
+              <a:t>4/9/2026</a:t>
             </a:fld>
             <a:endParaRPr lang="en-US"/>
           </a:p>
@@ -3600,7 +4284,7 @@
           <a:p>
             <a:fld id="{5BCAD085-E8A6-8845-BD4E-CB4CCA059FC4}" type="datetimeFigureOut">
               <a:rPr lang="en-US" smtClean="0"/>
-              <a:t>4/8/2026</a:t>
+              <a:t>4/9/2026</a:t>
             </a:fld>
             <a:endParaRPr lang="en-US"/>
           </a:p>
@@ -3852,7 +4536,7 @@
           <a:p>
             <a:fld id="{5BCAD085-E8A6-8845-BD4E-CB4CCA059FC4}" type="datetimeFigureOut">
               <a:rPr lang="en-US" smtClean="0"/>
-              <a:t>4/8/2026</a:t>
+              <a:t>4/9/2026</a:t>
             </a:fld>
             <a:endParaRPr lang="en-US"/>
           </a:p>
@@ -4063,7 +4747,7 @@
           <a:p>
             <a:fld id="{5BCAD085-E8A6-8845-BD4E-CB4CCA059FC4}" type="datetimeFigureOut">
               <a:rPr lang="en-US" smtClean="0"/>
-              <a:t>4/8/2026</a:t>
+              <a:t>4/9/2026</a:t>
             </a:fld>
             <a:endParaRPr lang="en-US"/>
           </a:p>
@@ -5014,6 +5698,23 @@
               </a:rPr>
               <a:t>Dr. Elyor </a:t>
             </a:r>
+            <a:r>
+              <a:rPr lang="en-US">
+                <a:solidFill>
+                  <a:schemeClr val="bg1"/>
+                </a:solidFill>
+                <a:latin typeface="Segoe UI" panose="020B0502040204020203" pitchFamily="34" charset="0"/>
+                <a:cs typeface="Segoe UI" panose="020B0502040204020203" pitchFamily="34" charset="0"/>
+              </a:rPr>
+              <a:t>Kodirov</a:t>
+            </a:r>
+            <a:endParaRPr lang="en-US" dirty="0">
+              <a:solidFill>
+                <a:schemeClr val="bg1"/>
+              </a:solidFill>
+              <a:latin typeface="Segoe UI" panose="020B0502040204020203" pitchFamily="34" charset="0"/>
+              <a:cs typeface="Segoe UI" panose="020B0502040204020203" pitchFamily="34" charset="0"/>
+            </a:endParaRPr>
           </a:p>
           <a:p>
             <a:pPr>
@@ -5299,13 +6000,22 @@
           <a:p>
             <a:pPr algn="r"/>
             <a:r>
+              <a:rPr lang="en-US" sz="900" b="0" i="0" dirty="0">
+                <a:solidFill>
+                  <a:srgbClr val="9B59B6"/>
+                </a:solidFill>
+                <a:latin typeface="Segoe UI"/>
+              </a:rPr>
+              <a:t>10</a:t>
+            </a:r>
+            <a:r>
               <a:rPr sz="900" b="0" i="0" dirty="0">
                 <a:solidFill>
                   <a:srgbClr val="9B59B6"/>
                 </a:solidFill>
                 <a:latin typeface="Segoe UI"/>
               </a:rPr>
-              <a:t>9 / 1</a:t>
+              <a:t> / 1</a:t>
             </a:r>
             <a:r>
               <a:rPr lang="en-US" sz="900" b="0" i="0" dirty="0">
@@ -5314,7 +6024,7 @@
                 </a:solidFill>
                 <a:latin typeface="Segoe UI"/>
               </a:rPr>
-              <a:t>7</a:t>
+              <a:t>8</a:t>
             </a:r>
             <a:endParaRPr sz="900" b="0" i="0" dirty="0">
               <a:solidFill>
@@ -6269,7 +6979,7 @@
                 </a:solidFill>
                 <a:latin typeface="Segoe UI"/>
               </a:rPr>
-              <a:t>10 / 1</a:t>
+              <a:t>1</a:t>
             </a:r>
             <a:r>
               <a:rPr lang="en-US" sz="900" b="0" i="0" dirty="0">
@@ -6278,7 +6988,25 @@
                 </a:solidFill>
                 <a:latin typeface="Segoe UI"/>
               </a:rPr>
-              <a:t>7</a:t>
+              <a:t>1</a:t>
+            </a:r>
+            <a:r>
+              <a:rPr sz="900" b="0" i="0" dirty="0">
+                <a:solidFill>
+                  <a:srgbClr val="9B59B6"/>
+                </a:solidFill>
+                <a:latin typeface="Segoe UI"/>
+              </a:rPr>
+              <a:t> / 1</a:t>
+            </a:r>
+            <a:r>
+              <a:rPr lang="en-US" sz="900" b="0" i="0" dirty="0">
+                <a:solidFill>
+                  <a:srgbClr val="9B59B6"/>
+                </a:solidFill>
+                <a:latin typeface="Segoe UI"/>
+              </a:rPr>
+              <a:t>8</a:t>
             </a:r>
             <a:endParaRPr sz="900" b="0" i="0" dirty="0">
               <a:solidFill>
@@ -6873,6 +7601,80 @@
               <a:t> confirms direction: high seller late rate strongly pushes toward late prediction. Purchase month and same-state delivery also show clear directional effects.</a:t>
             </a:r>
             <a:endParaRPr lang="en-US" dirty="0"/>
+          </a:p>
+        </p:txBody>
+      </p:sp>
+      <p:sp>
+        <p:nvSpPr>
+          <p:cNvPr id="2" name="TextBox 1">
+            <a:extLst>
+              <a:ext uri="{FF2B5EF4-FFF2-40B4-BE49-F238E27FC236}">
+                <a16:creationId xmlns:a16="http://schemas.microsoft.com/office/drawing/2014/main" id="{D0F1E4C4-89D4-01C8-FB86-3B13A4863673}"/>
+              </a:ext>
+            </a:extLst>
+          </p:cNvPr>
+          <p:cNvSpPr txBox="1"/>
+          <p:nvPr/>
+        </p:nvSpPr>
+        <p:spPr>
+          <a:xfrm>
+            <a:off x="11247120" y="6492240"/>
+            <a:ext cx="914400" cy="230832"/>
+          </a:xfrm>
+          <a:prstGeom prst="rect">
+            <a:avLst/>
+          </a:prstGeom>
+          <a:noFill/>
+        </p:spPr>
+        <p:txBody>
+          <a:bodyPr wrap="square">
+            <a:spAutoFit/>
+          </a:bodyPr>
+          <a:lstStyle/>
+          <a:p>
+            <a:pPr algn="r"/>
+            <a:r>
+              <a:rPr sz="900" b="0" i="0" dirty="0">
+                <a:solidFill>
+                  <a:srgbClr val="9B59B6"/>
+                </a:solidFill>
+                <a:latin typeface="Segoe UI"/>
+              </a:rPr>
+              <a:t>1</a:t>
+            </a:r>
+            <a:r>
+              <a:rPr lang="en-US" sz="900" b="0" i="0" dirty="0">
+                <a:solidFill>
+                  <a:srgbClr val="9B59B6"/>
+                </a:solidFill>
+                <a:latin typeface="Segoe UI"/>
+              </a:rPr>
+              <a:t>2</a:t>
+            </a:r>
+            <a:r>
+              <a:rPr sz="900" b="0" i="0" dirty="0">
+                <a:solidFill>
+                  <a:srgbClr val="9B59B6"/>
+                </a:solidFill>
+                <a:latin typeface="Segoe UI"/>
+              </a:rPr>
+              <a:t> / 1</a:t>
+            </a:r>
+            <a:r>
+              <a:rPr lang="en-US" sz="900" b="0" i="0" dirty="0">
+                <a:solidFill>
+                  <a:srgbClr val="9B59B6"/>
+                </a:solidFill>
+                <a:latin typeface="Segoe UI"/>
+              </a:rPr>
+              <a:t>8</a:t>
+            </a:r>
+            <a:endParaRPr sz="900" b="0" i="0" dirty="0">
+              <a:solidFill>
+                <a:srgbClr val="9B59B6"/>
+              </a:solidFill>
+              <a:latin typeface="Segoe UI"/>
+            </a:endParaRPr>
           </a:p>
         </p:txBody>
       </p:sp>
@@ -6948,7 +7750,7 @@
                 </a:solidFill>
                 <a:latin typeface="Segoe UI"/>
               </a:rPr>
-              <a:t>10 / 1</a:t>
+              <a:t>1</a:t>
             </a:r>
             <a:r>
               <a:rPr lang="en-US" sz="900" b="0" i="0" dirty="0">
@@ -6957,7 +7759,25 @@
                 </a:solidFill>
                 <a:latin typeface="Segoe UI"/>
               </a:rPr>
-              <a:t>7</a:t>
+              <a:t>3</a:t>
+            </a:r>
+            <a:r>
+              <a:rPr sz="900" b="0" i="0" dirty="0">
+                <a:solidFill>
+                  <a:srgbClr val="9B59B6"/>
+                </a:solidFill>
+                <a:latin typeface="Segoe UI"/>
+              </a:rPr>
+              <a:t> / 1</a:t>
+            </a:r>
+            <a:r>
+              <a:rPr lang="en-US" sz="900" b="0" i="0" dirty="0">
+                <a:solidFill>
+                  <a:srgbClr val="9B59B6"/>
+                </a:solidFill>
+                <a:latin typeface="Segoe UI"/>
+              </a:rPr>
+              <a:t>8</a:t>
             </a:r>
             <a:endParaRPr sz="900" b="0" i="0" dirty="0">
               <a:solidFill>
@@ -7164,7 +7984,7 @@
           <p:nvPr/>
         </p:nvPicPr>
         <p:blipFill>
-          <a:blip r:embed="rId2"/>
+          <a:blip r:embed="rId3"/>
           <a:stretch>
             <a:fillRect/>
           </a:stretch>
@@ -7194,7 +8014,7 @@
           <p:nvPr/>
         </p:nvPicPr>
         <p:blipFill>
-          <a:blip r:embed="rId3"/>
+          <a:blip r:embed="rId4"/>
           <a:stretch>
             <a:fillRect/>
           </a:stretch>
@@ -7496,7 +8316,7 @@
           <p:nvPr/>
         </p:nvPicPr>
         <p:blipFill>
-          <a:blip r:embed="rId2"/>
+          <a:blip r:embed="rId3"/>
           <a:stretch>
             <a:fillRect/>
           </a:stretch>
@@ -7525,10 +8345,10 @@
         </p:nvGrpSpPr>
         <p:grpSpPr>
           <a:xfrm>
-            <a:off x="653732" y="5934456"/>
-            <a:ext cx="11142028" cy="960120"/>
+            <a:off x="653732" y="5971032"/>
+            <a:ext cx="10881361" cy="923544"/>
             <a:chOff x="365760" y="5897880"/>
-            <a:chExt cx="11142028" cy="960120"/>
+            <a:chExt cx="11197900" cy="960120"/>
           </a:xfrm>
         </p:grpSpPr>
         <p:grpSp>
@@ -7862,9 +8682,9 @@
           <p:grpSpPr>
             <a:xfrm>
               <a:off x="7772400" y="5897880"/>
-              <a:ext cx="3735388" cy="960120"/>
+              <a:ext cx="3791260" cy="960120"/>
               <a:chOff x="7772400" y="5897880"/>
-              <a:chExt cx="3735388" cy="960120"/>
+              <a:chExt cx="3791260" cy="960120"/>
             </a:xfrm>
           </p:grpSpPr>
           <p:sp>
@@ -7973,7 +8793,7 @@
             <p:spPr>
               <a:xfrm>
                 <a:off x="8942832" y="5934456"/>
-                <a:ext cx="2532888" cy="698525"/>
+                <a:ext cx="2620828" cy="726189"/>
               </a:xfrm>
               <a:prstGeom prst="rect">
                 <a:avLst/>
@@ -8006,6 +8826,80 @@
           </p:sp>
         </p:grpSp>
       </p:grpSp>
+      <p:sp>
+        <p:nvSpPr>
+          <p:cNvPr id="3" name="TextBox 2">
+            <a:extLst>
+              <a:ext uri="{FF2B5EF4-FFF2-40B4-BE49-F238E27FC236}">
+                <a16:creationId xmlns:a16="http://schemas.microsoft.com/office/drawing/2014/main" id="{81015ADB-CE28-91AF-4F92-582DE39AC5A0}"/>
+              </a:ext>
+            </a:extLst>
+          </p:cNvPr>
+          <p:cNvSpPr txBox="1"/>
+          <p:nvPr/>
+        </p:nvSpPr>
+        <p:spPr>
+          <a:xfrm>
+            <a:off x="11247120" y="6492240"/>
+            <a:ext cx="914400" cy="230832"/>
+          </a:xfrm>
+          <a:prstGeom prst="rect">
+            <a:avLst/>
+          </a:prstGeom>
+          <a:noFill/>
+        </p:spPr>
+        <p:txBody>
+          <a:bodyPr wrap="square">
+            <a:spAutoFit/>
+          </a:bodyPr>
+          <a:lstStyle/>
+          <a:p>
+            <a:pPr algn="r"/>
+            <a:r>
+              <a:rPr sz="900" b="0" i="0" dirty="0">
+                <a:solidFill>
+                  <a:srgbClr val="9B59B6"/>
+                </a:solidFill>
+                <a:latin typeface="Segoe UI"/>
+              </a:rPr>
+              <a:t>1</a:t>
+            </a:r>
+            <a:r>
+              <a:rPr lang="en-US" sz="900" b="0" i="0" dirty="0">
+                <a:solidFill>
+                  <a:srgbClr val="9B59B6"/>
+                </a:solidFill>
+                <a:latin typeface="Segoe UI"/>
+              </a:rPr>
+              <a:t>4</a:t>
+            </a:r>
+            <a:r>
+              <a:rPr sz="900" b="0" i="0" dirty="0">
+                <a:solidFill>
+                  <a:srgbClr val="9B59B6"/>
+                </a:solidFill>
+                <a:latin typeface="Segoe UI"/>
+              </a:rPr>
+              <a:t> / 1</a:t>
+            </a:r>
+            <a:r>
+              <a:rPr lang="en-US" sz="900" b="0" i="0" dirty="0">
+                <a:solidFill>
+                  <a:srgbClr val="9B59B6"/>
+                </a:solidFill>
+                <a:latin typeface="Segoe UI"/>
+              </a:rPr>
+              <a:t>8</a:t>
+            </a:r>
+            <a:endParaRPr sz="900" b="0" i="0" dirty="0">
+              <a:solidFill>
+                <a:srgbClr val="9B59B6"/>
+              </a:solidFill>
+              <a:latin typeface="Segoe UI"/>
+            </a:endParaRPr>
+          </a:p>
+        </p:txBody>
+      </p:sp>
     </p:spTree>
   </p:cSld>
   <p:clrMapOvr>
@@ -8061,7 +8955,7 @@
                 </a:solidFill>
                 <a:latin typeface="Segoe UI"/>
               </a:rPr>
-              <a:t>12 / 1</a:t>
+              <a:t>1</a:t>
             </a:r>
             <a:r>
               <a:rPr lang="en-US" sz="1050" b="0" i="0" dirty="0">
@@ -8070,7 +8964,25 @@
                 </a:solidFill>
                 <a:latin typeface="Segoe UI"/>
               </a:rPr>
-              <a:t>7</a:t>
+              <a:t>5</a:t>
+            </a:r>
+            <a:r>
+              <a:rPr sz="1050" b="0" i="0" dirty="0">
+                <a:solidFill>
+                  <a:srgbClr val="9B59B6"/>
+                </a:solidFill>
+                <a:latin typeface="Segoe UI"/>
+              </a:rPr>
+              <a:t> / 1</a:t>
+            </a:r>
+            <a:r>
+              <a:rPr lang="en-US" sz="1050" b="0" i="0" dirty="0">
+                <a:solidFill>
+                  <a:srgbClr val="9B59B6"/>
+                </a:solidFill>
+                <a:latin typeface="Segoe UI"/>
+              </a:rPr>
+              <a:t>8</a:t>
             </a:r>
             <a:endParaRPr sz="1050" b="0" i="0" dirty="0">
               <a:solidFill>
@@ -10858,7 +11770,7 @@
                 </a:solidFill>
                 <a:latin typeface="Segoe UI"/>
               </a:rPr>
-              <a:t>14 / 1</a:t>
+              <a:t>1</a:t>
             </a:r>
             <a:r>
               <a:rPr lang="en-US" sz="900" b="0" i="0" dirty="0">
@@ -10867,7 +11779,25 @@
                 </a:solidFill>
                 <a:latin typeface="Segoe UI"/>
               </a:rPr>
-              <a:t>7</a:t>
+              <a:t>6</a:t>
+            </a:r>
+            <a:r>
+              <a:rPr sz="900" b="0" i="0" dirty="0">
+                <a:solidFill>
+                  <a:srgbClr val="9B59B6"/>
+                </a:solidFill>
+                <a:latin typeface="Segoe UI"/>
+              </a:rPr>
+              <a:t> / 1</a:t>
+            </a:r>
+            <a:r>
+              <a:rPr lang="en-US" sz="900" b="0" i="0" dirty="0">
+                <a:solidFill>
+                  <a:srgbClr val="9B59B6"/>
+                </a:solidFill>
+                <a:latin typeface="Segoe UI"/>
+              </a:rPr>
+              <a:t>8</a:t>
             </a:r>
             <a:endParaRPr sz="900" b="0" i="0" dirty="0">
               <a:solidFill>
@@ -10886,7 +11816,7 @@
         </p:nvSpPr>
         <p:spPr>
           <a:xfrm>
-            <a:off x="0" y="0"/>
+            <a:off x="-2044700" y="-41435"/>
             <a:ext cx="12188952" cy="1005840"/>
           </a:xfrm>
           <a:prstGeom prst="rect">
@@ -11031,17 +11961,41 @@
                 </a:solidFill>
                 <a:latin typeface="Segoe UI"/>
               </a:rPr>
-              <a:t>Name</a:t>
-            </a:r>
-            <a:endParaRPr sz="2600" b="1" i="0" dirty="0">
-              <a:solidFill>
-                <a:srgbClr val="FFFFFF"/>
-              </a:solidFill>
-              <a:latin typeface="Segoe UI"/>
-            </a:endParaRPr>
-          </a:p>
-        </p:txBody>
-      </p:sp>
+              <a:t>Tableau Dashboard</a:t>
+            </a:r>
+          </a:p>
+        </p:txBody>
+      </p:sp>
+      <p:pic>
+        <p:nvPicPr>
+          <p:cNvPr id="8" name="Picture 7">
+            <a:extLst>
+              <a:ext uri="{FF2B5EF4-FFF2-40B4-BE49-F238E27FC236}">
+                <a16:creationId xmlns:a16="http://schemas.microsoft.com/office/drawing/2014/main" id="{9F9649BB-0BD6-B8D0-AC87-C8C6DDAF53F1}"/>
+              </a:ext>
+            </a:extLst>
+          </p:cNvPr>
+          <p:cNvPicPr>
+            <a:picLocks noChangeAspect="1"/>
+          </p:cNvPicPr>
+          <p:nvPr/>
+        </p:nvPicPr>
+        <p:blipFill>
+          <a:blip r:embed="rId3"/>
+          <a:stretch>
+            <a:fillRect/>
+          </a:stretch>
+        </p:blipFill>
+        <p:spPr>
+          <a:xfrm>
+            <a:off x="1191893" y="1048165"/>
+            <a:ext cx="9805038" cy="5553803"/>
+          </a:xfrm>
+          <a:prstGeom prst="rect">
+            <a:avLst/>
+          </a:prstGeom>
+        </p:spPr>
+      </p:pic>
     </p:spTree>
   </p:cSld>
   <p:clrMapOvr>
@@ -11097,7 +12051,7 @@
                 </a:solidFill>
                 <a:latin typeface="Segoe UI"/>
               </a:rPr>
-              <a:t>15 / 1</a:t>
+              <a:t>1</a:t>
             </a:r>
             <a:r>
               <a:rPr lang="en-US" sz="900" b="0" i="0" dirty="0">
@@ -11107,6 +12061,24 @@
                 <a:latin typeface="Segoe UI"/>
               </a:rPr>
               <a:t>7</a:t>
+            </a:r>
+            <a:r>
+              <a:rPr sz="900" b="0" i="0" dirty="0">
+                <a:solidFill>
+                  <a:srgbClr val="9B59B6"/>
+                </a:solidFill>
+                <a:latin typeface="Segoe UI"/>
+              </a:rPr>
+              <a:t> / 1</a:t>
+            </a:r>
+            <a:r>
+              <a:rPr lang="en-US" sz="900" b="0" i="0" dirty="0">
+                <a:solidFill>
+                  <a:srgbClr val="9B59B6"/>
+                </a:solidFill>
+                <a:latin typeface="Segoe UI"/>
+              </a:rPr>
+              <a:t>8</a:t>
             </a:r>
             <a:endParaRPr sz="900" b="0" i="0" dirty="0">
               <a:solidFill>
@@ -12558,7 +13530,7 @@
                 </a:solidFill>
                 <a:latin typeface="Segoe UI"/>
               </a:rPr>
-              <a:t>7</a:t>
+              <a:t>8</a:t>
             </a:r>
             <a:endParaRPr sz="900" b="0" i="0" dirty="0">
               <a:solidFill>
@@ -14439,7 +15411,7 @@
                 </a:solidFill>
                 <a:latin typeface="Segoe UI"/>
               </a:rPr>
-              <a:t>7</a:t>
+              <a:t>8</a:t>
             </a:r>
             <a:endParaRPr sz="900" b="0" i="0" dirty="0">
               <a:solidFill>
@@ -15492,7 +16464,7 @@
                 </a:solidFill>
                 <a:latin typeface="Segoe UI"/>
               </a:rPr>
-              <a:t>7</a:t>
+              <a:t>8</a:t>
             </a:r>
             <a:endParaRPr sz="900" b="0" i="0" dirty="0">
               <a:solidFill>
@@ -18168,7 +19140,7 @@
                 </a:solidFill>
                 <a:latin typeface="Segoe UI"/>
               </a:rPr>
-              <a:t>7</a:t>
+              <a:t>8</a:t>
             </a:r>
             <a:endParaRPr sz="900" b="0" i="0" dirty="0">
               <a:solidFill>
@@ -19047,13 +20019,22 @@
           <a:p>
             <a:pPr algn="r"/>
             <a:r>
+              <a:rPr lang="en-US" sz="900" dirty="0">
+                <a:solidFill>
+                  <a:srgbClr val="9B59B6"/>
+                </a:solidFill>
+                <a:latin typeface="Segoe UI"/>
+              </a:rPr>
+              <a:t>6</a:t>
+            </a:r>
+            <a:r>
               <a:rPr sz="900" b="0" i="0" dirty="0">
                 <a:solidFill>
                   <a:srgbClr val="9B59B6"/>
                 </a:solidFill>
                 <a:latin typeface="Segoe UI"/>
               </a:rPr>
-              <a:t>7 / 1</a:t>
+              <a:t> / 1</a:t>
             </a:r>
             <a:r>
               <a:rPr lang="en-US" sz="900" b="0" i="0" dirty="0">
@@ -19062,7 +20043,7 @@
                 </a:solidFill>
                 <a:latin typeface="Segoe UI"/>
               </a:rPr>
-              <a:t>7</a:t>
+              <a:t>8</a:t>
             </a:r>
             <a:endParaRPr sz="900" b="0" i="0" dirty="0">
               <a:solidFill>
@@ -20191,7 +21172,7 @@
                 </a:solidFill>
                 <a:latin typeface="Segoe UI"/>
               </a:rPr>
-              <a:t>7</a:t>
+              <a:t>8</a:t>
             </a:r>
             <a:endParaRPr sz="900" b="0" i="0" dirty="0">
               <a:solidFill>
@@ -23329,13 +24310,22 @@
           <a:p>
             <a:pPr algn="r"/>
             <a:r>
+              <a:rPr lang="en-US" sz="900" b="0" i="0" dirty="0">
+                <a:solidFill>
+                  <a:srgbClr val="9B59B6"/>
+                </a:solidFill>
+                <a:latin typeface="Segoe UI"/>
+              </a:rPr>
+              <a:t>9</a:t>
+            </a:r>
+            <a:r>
               <a:rPr sz="900" b="0" i="0" dirty="0">
                 <a:solidFill>
                   <a:srgbClr val="9B59B6"/>
                 </a:solidFill>
                 <a:latin typeface="Segoe UI"/>
               </a:rPr>
-              <a:t>8 / 1</a:t>
+              <a:t>/ 1</a:t>
             </a:r>
             <a:r>
               <a:rPr lang="en-US" sz="900" b="0" i="0" dirty="0">
@@ -23344,7 +24334,7 @@
                 </a:solidFill>
                 <a:latin typeface="Segoe UI"/>
               </a:rPr>
-              <a:t>7</a:t>
+              <a:t>8</a:t>
             </a:r>
             <a:endParaRPr sz="900" b="0" i="0" dirty="0">
               <a:solidFill>

</xml_diff>